<commit_message>
W02/D1 decks: every leaf against Week 1 (S12a, S12b), rupees and orders separated in S8 and S9, decks rebuilt
Co-Authored-By: Claude Opus 5.5 <noreply@anthropic.com>
Claude-Session: https://claude.ai/code/session_01EVA84TBRW8hq3iVvrgvxPL
</commit_message>
<xml_diff>
--- a/content/W02/D1/slides/C2_W02_D01_half2_STUDENT.pptx
+++ b/content/W02/D1/slides/C2_W02_D01_half2_STUDENT.pptx
@@ -674,7 +674,22 @@
           <a:lstStyle/>
           <a:p>
             <a:r>
-              <a:t>LIVE, 2 minutes. Frequency is the branch that fell furthest, which is Week 1's finding at warehouse</a:t>
+              <a:t>LIVE, 2 minutes. Ask two questions and take an answer to each. Where did the rupees fall?</a:t>
+            </a:r>
+          </a:p>
+          <a:p>
+            <a:r>
+              <a:t>Business: it carries 99.1 percent of revenue, so its 1.4 percent dip is Rs 14,29,840 of the</a:t>
+            </a:r>
+          </a:p>
+          <a:p>
+            <a:r>
+              <a:t>Rs 16,00,000 fall. Where did the orders and the frequency fall? Retail-Plus: it lost 75 of the</a:t>
+            </a:r>
+          </a:p>
+          <a:p>
+            <a:r>
+              <a:t>book's 76 fewer orders, and its frequency fell furthest, which is Week 1's lever at warehouse</a:t>
             </a:r>
           </a:p>
           <a:p>
@@ -754,7 +769,12 @@
           </a:p>
           <a:p>
             <a:r>
-              <a:t>percent against query 1.</a:t>
+              <a:t>percent against query 1. Then ask why the evidence has two halves: rupees and orders are different</a:t>
+            </a:r>
+          </a:p>
+          <a:p>
+            <a:r>
+              <a:t>questions, and here they have different answers.</a:t>
             </a:r>
           </a:p>
         </p:txBody>
@@ -6589,7 +6609,7 @@
                 </a:solidFill>
                 <a:latin typeface="Georgia"/>
               </a:rPr>
-              <a:t>What the suite says: Retail-Plus moved</a:t>
+              <a:t>What the suite says: two questions, two answers</a:t>
             </a:r>
           </a:p>
         </p:txBody>
@@ -6624,7 +6644,7 @@
                 </a:solidFill>
                 <a:latin typeface="Calibri"/>
               </a:rPr>
-              <a:t>Query 6, the one row per segment Anand reads first.</a:t>
+              <a:t>Query 6 in percent, and query 3's revenue turned into rupees.</a:t>
             </a:r>
           </a:p>
         </p:txBody>
@@ -6648,11 +6668,12 @@
                 <a:tableStyleId>{2D5ABB26-0587-4C30-8999-92F81FD0307C}</a:tableStyleId>
               </a:tblPr>
               <a:tblGrid>
-                <a:gridCol w="2276408"/>
-                <a:gridCol w="2124456"/>
-                <a:gridCol w="2124456"/>
-                <a:gridCol w="2494426"/>
-                <a:gridCol w="2111243"/>
+                <a:gridCol w="1759827"/>
+                <a:gridCol w="1642357"/>
+                <a:gridCol w="1642357"/>
+                <a:gridCol w="1928371"/>
+                <a:gridCol w="1632142"/>
+                <a:gridCol w="2525935"/>
               </a:tblGrid>
               <a:tr h="335280">
                 <a:tc>
@@ -6756,6 +6777,28 @@
                           <a:latin typeface="Calibri"/>
                         </a:rPr>
                         <a:t>Revenue</a:t>
+                      </a:r>
+                    </a:p>
+                  </a:txBody>
+                  <a:tcPr marL="101600" marR="101600" marT="38100" marB="38100" anchor="ctr">
+                    <a:solidFill>
+                      <a:srgbClr val="1A0F5C"/>
+                    </a:solidFill>
+                  </a:tcPr>
+                </a:tc>
+                <a:tc>
+                  <a:txBody>
+                    <a:bodyPr/>
+                    <a:lstStyle/>
+                    <a:p>
+                      <a:r>
+                        <a:rPr sz="1250" b="1" i="0">
+                          <a:solidFill>
+                            <a:srgbClr val="FFFFFF"/>
+                          </a:solidFill>
+                          <a:latin typeface="Calibri"/>
+                        </a:rPr>
+                        <a:t>Rupees moved</a:t>
                       </a:r>
                     </a:p>
                   </a:txBody>
@@ -6877,6 +6920,28 @@
                     </a:solidFill>
                   </a:tcPr>
                 </a:tc>
+                <a:tc>
+                  <a:txBody>
+                    <a:bodyPr/>
+                    <a:lstStyle/>
+                    <a:p>
+                      <a:r>
+                        <a:rPr sz="1200" b="0" i="0">
+                          <a:solidFill>
+                            <a:srgbClr val="1A1440"/>
+                          </a:solidFill>
+                          <a:latin typeface="Calibri"/>
+                        </a:rPr>
+                        <a:t>Rs 14,29,840 down</a:t>
+                      </a:r>
+                    </a:p>
+                  </a:txBody>
+                  <a:tcPr marL="101600" marR="101600" marT="38100" marB="38100" anchor="ctr">
+                    <a:solidFill>
+                      <a:srgbClr val="FFFFFF"/>
+                    </a:solidFill>
+                  </a:tcPr>
+                </a:tc>
               </a:tr>
               <a:tr h="335280">
                 <a:tc>
@@ -6980,6 +7045,28 @@
                           <a:latin typeface="Calibri"/>
                         </a:rPr>
                         <a:t>1.8% down</a:t>
+                      </a:r>
+                    </a:p>
+                  </a:txBody>
+                  <a:tcPr marL="101600" marR="101600" marT="38100" marB="38100" anchor="ctr">
+                    <a:solidFill>
+                      <a:srgbClr val="F4F2FA"/>
+                    </a:solidFill>
+                  </a:tcPr>
+                </a:tc>
+                <a:tc>
+                  <a:txBody>
+                    <a:bodyPr/>
+                    <a:lstStyle/>
+                    <a:p>
+                      <a:r>
+                        <a:rPr sz="1200" b="0" i="0">
+                          <a:solidFill>
+                            <a:srgbClr val="1A1440"/>
+                          </a:solidFill>
+                          <a:latin typeface="Calibri"/>
+                        </a:rPr>
+                        <a:t>Rs 6,820 down</a:t>
                       </a:r>
                     </a:p>
                   </a:txBody>
@@ -7101,6 +7188,28 @@
                     </a:solidFill>
                   </a:tcPr>
                 </a:tc>
+                <a:tc>
+                  <a:txBody>
+                    <a:bodyPr/>
+                    <a:lstStyle/>
+                    <a:p>
+                      <a:r>
+                        <a:rPr sz="1200" b="0" i="0">
+                          <a:solidFill>
+                            <a:srgbClr val="1A1440"/>
+                          </a:solidFill>
+                          <a:latin typeface="Calibri"/>
+                        </a:rPr>
+                        <a:t>Rs 1,72,390 down</a:t>
+                      </a:r>
+                    </a:p>
+                  </a:txBody>
+                  <a:tcPr marL="101600" marR="101600" marT="38100" marB="38100" anchor="ctr">
+                    <a:solidFill>
+                      <a:srgbClr val="FFFFFF"/>
+                    </a:solidFill>
+                  </a:tcPr>
+                </a:tc>
               </a:tr>
               <a:tr h="335280">
                 <a:tc>
@@ -7213,6 +7322,28 @@
                     </a:solidFill>
                   </a:tcPr>
                 </a:tc>
+                <a:tc>
+                  <a:txBody>
+                    <a:bodyPr/>
+                    <a:lstStyle/>
+                    <a:p>
+                      <a:r>
+                        <a:rPr sz="1200" b="0" i="0">
+                          <a:solidFill>
+                            <a:srgbClr val="1A1440"/>
+                          </a:solidFill>
+                          <a:latin typeface="Calibri"/>
+                        </a:rPr>
+                        <a:t>Rs 9,050 up</a:t>
+                      </a:r>
+                    </a:p>
+                  </a:txBody>
+                  <a:tcPr marL="101600" marR="101600" marT="38100" marB="38100" anchor="ctr">
+                    <a:solidFill>
+                      <a:srgbClr val="F4F2FA"/>
+                    </a:solidFill>
+                  </a:tcPr>
+                </a:tc>
               </a:tr>
             </a:tbl>
           </a:graphicData>
@@ -7887,7 +8018,7 @@
                 </a:solidFill>
                 <a:latin typeface="Calibri"/>
               </a:rPr>
-              <a:t>Booked revenue fell 1.6 percent from Q1 to Q2, the same fall last week's extract showed, so the warehouse agrees with the note Meera accepted.</a:t>
+              <a:t>Booked revenue fell 1.6 percent from Q1 to Q2, Rs 16,00,000, the same rate last week's file showed.</a:t>
             </a:r>
           </a:p>
         </p:txBody>
@@ -7901,7 +8032,7 @@
         <p:spPr>
           <a:xfrm>
             <a:off x="530352" y="3689794"/>
-            <a:ext cx="11130991" cy="807720"/>
+            <a:ext cx="11130991" cy="1074420"/>
           </a:xfrm>
           <a:prstGeom prst="roundRect">
             <a:avLst>
@@ -7949,7 +8080,7 @@
         <p:spPr>
           <a:xfrm>
             <a:off x="676656" y="3817810"/>
-            <a:ext cx="45720" cy="551688"/>
+            <a:ext cx="45720" cy="818388"/>
           </a:xfrm>
           <a:prstGeom prst="roundRect">
             <a:avLst>
@@ -7995,7 +8126,7 @@
         <p:spPr>
           <a:xfrm>
             <a:off x="877824" y="3808666"/>
-            <a:ext cx="10564063" cy="624840"/>
+            <a:ext cx="10564063" cy="891540"/>
           </a:xfrm>
           <a:prstGeom prst="rect">
             <a:avLst/>
@@ -8024,7 +8155,7 @@
                 </a:solidFill>
                 <a:latin typeface="Calibri"/>
               </a:rPr>
-              <a:t>The fall sits in Retail-Plus, down 29.4 percent: its members ordered less often, 2.36 to 1.84 per quarter, and fewer bought at all, 91 to 76; the other segments moved under 2 percent or grew.</a:t>
+              <a:t>The rupees fell in Business, which carries 99.1 percent of revenue and lost Rs 14,29,840 on a 1.4 percent dip. The orders fell in Retail-Plus: it lost 75 of the book's 76 fewer orders, its members ordered less often, 2.36 to 1.84 per quarter, and fewer bought at all, 91 to 76.</a:t>
             </a:r>
           </a:p>
         </p:txBody>
@@ -8037,7 +8168,7 @@
         </p:nvSpPr>
         <p:spPr>
           <a:xfrm>
-            <a:off x="530352" y="4662106"/>
+            <a:off x="530352" y="4928806"/>
             <a:ext cx="11130991" cy="807720"/>
           </a:xfrm>
           <a:prstGeom prst="roundRect">
@@ -8085,7 +8216,7 @@
         </p:nvSpPr>
         <p:spPr>
           <a:xfrm>
-            <a:off x="676656" y="4790122"/>
+            <a:off x="676656" y="5056822"/>
             <a:ext cx="45720" cy="551688"/>
           </a:xfrm>
           <a:prstGeom prst="roundRect">
@@ -8131,7 +8262,7 @@
         </p:nvSpPr>
         <p:spPr>
           <a:xfrm>
-            <a:off x="877824" y="4780978"/>
+            <a:off x="877824" y="5047678"/>
             <a:ext cx="10564063" cy="624840"/>
           </a:xfrm>
           <a:prstGeom prst="rect">
@@ -8161,7 +8292,7 @@
                 </a:solidFill>
                 <a:latin typeface="Calibri"/>
               </a:rPr>
-              <a:t>This is booked revenue; Student's Q1 rate rests on 27 orders. </a:t>
+              <a:t>This is booked revenue; Student's Q1 rate rests on 27 orders; the warehouse counts different customers from last week's file and is the book of record. </a:t>
             </a:r>
             <a:r>
               <a:rPr sz="1500" b="1" i="0">
@@ -8927,7 +9058,7 @@
                 </a:solidFill>
                 <a:latin typeface="Calibri"/>
               </a:rPr>
-              <a:t>Week 2 Day 1: the Monday numbers, from the warehouse</a:t>
+              <a:t>Week 2, Day 1. The Monday suite</a:t>
             </a:r>
           </a:p>
         </p:txBody>
@@ -14429,7 +14560,7 @@
                 </a:solidFill>
                 <a:latin typeface="Calibri"/>
               </a:rPr>
-              <a:t>Week 2 Day 1: the Monday numbers, from the warehouse</a:t>
+              <a:t>Week 2, Day 1. The Monday suite</a:t>
             </a:r>
           </a:p>
         </p:txBody>
@@ -19406,7 +19537,7 @@
                 </a:solidFill>
                 <a:latin typeface="Calibri"/>
               </a:rPr>
-              <a:t>Week 2 Day 1: the Monday numbers, from the warehouse</a:t>
+              <a:t>Week 2, Day 1. The Monday suite</a:t>
             </a:r>
           </a:p>
         </p:txBody>

</xml_diff>

<commit_message>
W02 D1: the real-company facts as checked on 30 September 2026: Airbnb's post title in its own sentence case and the story as years earlier, GitLab's CTE sentence quoted with its cut marked, and Netflix's audit told as its talk sets it, the row-count checks failing the job and the missing-value check only warning; the JPMorgan slide carries the report's page 7 figure
Co-Authored-By: Claude Opus 5.5 <noreply@anthropic.com>
Claude-Session: https://claude.ai/code/session_014GEPri7CeveWYL6asG7gwT
</commit_message>
<xml_diff>
--- a/content/W02/D1/slides/C2_W02_D01_half2_STUDENT.pptx
+++ b/content/W02/D1/slides/C2_W02_D01_half2_STUDENT.pptx
@@ -2428,22 +2428,27 @@
           <a:lstStyle/>
           <a:p>
             <a:r>
-              <a:t>LIVE, 1 minute. Michelle Ufford's talk "Whoops, the Numbers are wrong! Scaling Data Quality @</a:t>
-            </a:r>
-          </a:p>
-          <a:p>
-            <a:r>
-              <a:t>Netflix" at the DataWorks and Hadoop Summit, June 2017. One of its slides sets a new batch of</a:t>
-            </a:r>
-          </a:p>
-          <a:p>
-            <a:r>
-              <a:t>17,240 rows with 17,240 missing values beside the previous day's 16,135 rows with 21: every value</a:t>
-            </a:r>
-          </a:p>
-          <a:p>
-            <a:r>
-              <a:t>of the column was missing, and the audit exists to stop that batch. Source and check date are in</a:t>
+              <a:t>LIVE, 1 minute. Michelle Ufford's talk "Whoops, The Numbers Are Wrong! Scaling Data Quality @</a:t>
+            </a:r>
+          </a:p>
+          <a:p>
+            <a:r>
+              <a:t>Netflix" at DataWorks Summit, San Jose, 13 June 2017. One of its slides sets a new batch of 17,240</a:t>
+            </a:r>
+          </a:p>
+          <a:p>
+            <a:r>
+              <a:t>rows with 17,240 missing values beside the previous day's 16,135 rows with 21: every value of the</a:t>
+            </a:r>
+          </a:p>
+          <a:p>
+            <a:r>
+              <a:t>column was missing. In the talk's rules the row-count checks fail the job and the missing-value</a:t>
+            </a:r>
+          </a:p>
+          <a:p>
+            <a:r>
+              <a:t>check only warns, so that batch raised a warning; say it that way. Source and check date are in</a:t>
             </a:r>
           </a:p>
           <a:p>
@@ -29224,7 +29229,7 @@
       </p:sp>
       <p:pic>
         <p:nvPicPr>
-          <p:cNvPr id="9" name="mermaid diagram" descr="0ac4d55538496294.png"/>
+          <p:cNvPr id="9" name="mermaid diagram" descr="4cd06380afdb5b42.png"/>
           <p:cNvPicPr>
             <a:picLocks noChangeAspect="1"/>
           </p:cNvPicPr>
@@ -29238,8 +29243,8 @@
         </p:blipFill>
         <p:spPr>
           <a:xfrm>
-            <a:off x="1445266" y="1956816"/>
-            <a:ext cx="9301162" cy="2786062"/>
+            <a:off x="1180947" y="1956816"/>
+            <a:ext cx="9829800" cy="2786062"/>
           </a:xfrm>
           <a:prstGeom prst="rect">
             <a:avLst/>

</xml_diff>

<commit_message>
W02 D1 decks rebuilt on main's deck builder, whose render cache now keys on the mermaid-cli version
Co-Authored-By: Claude Opus 5.5 <noreply@anthropic.com>
Claude-Session: https://claude.ai/code/session_01PqxrUdd3MVkcqi5tJL4ifU
</commit_message>
<xml_diff>
--- a/content/W02/D1/slides/C2_W02_D01_half2_STUDENT.pptx
+++ b/content/W02/D1/slides/C2_W02_D01_half2_STUDENT.pptx
@@ -10050,7 +10050,7 @@
       </p:sp>
       <p:pic>
         <p:nvPicPr>
-          <p:cNvPr id="9" name="mermaid diagram" descr="7647d511fe64edd1.png"/>
+          <p:cNvPr id="9" name="mermaid diagram" descr="3bc846f50e9698f3.png"/>
           <p:cNvPicPr>
             <a:picLocks noChangeAspect="1"/>
           </p:cNvPicPr>
@@ -11955,7 +11955,7 @@
       </p:sp>
       <p:pic>
         <p:nvPicPr>
-          <p:cNvPr id="9" name="mermaid diagram" descr="b2475a8e6bd693c1.png"/>
+          <p:cNvPr id="9" name="mermaid diagram" descr="1d703620b9331bd1.png"/>
           <p:cNvPicPr>
             <a:picLocks noChangeAspect="1"/>
           </p:cNvPicPr>
@@ -12611,7 +12611,7 @@
       </p:sp>
       <p:pic>
         <p:nvPicPr>
-          <p:cNvPr id="11" name="mermaid diagram" descr="0976b04f81f9508f.png"/>
+          <p:cNvPr id="11" name="mermaid diagram" descr="0d46d70744d0d965.png"/>
           <p:cNvPicPr>
             <a:picLocks noChangeAspect="1"/>
           </p:cNvPicPr>
@@ -22760,7 +22760,7 @@
       </p:sp>
       <p:pic>
         <p:nvPicPr>
-          <p:cNvPr id="21" name="mermaid diagram" descr="f29a3ab81528a198.png"/>
+          <p:cNvPr id="21" name="mermaid diagram" descr="82879d0b5e755ad7.png"/>
           <p:cNvPicPr>
             <a:picLocks noChangeAspect="1"/>
           </p:cNvPicPr>
@@ -24491,7 +24491,7 @@
       </p:sp>
       <p:pic>
         <p:nvPicPr>
-          <p:cNvPr id="10" name="mermaid diagram" descr="6a6d9ee5681df4b3.png"/>
+          <p:cNvPr id="10" name="mermaid diagram" descr="7dafdf7130c06c0d.png"/>
           <p:cNvPicPr>
             <a:picLocks noChangeAspect="1"/>
           </p:cNvPicPr>
@@ -26495,7 +26495,7 @@
       </p:sp>
       <p:pic>
         <p:nvPicPr>
-          <p:cNvPr id="13" name="mermaid diagram" descr="6055f7d26d6b54f8.png"/>
+          <p:cNvPr id="13" name="mermaid diagram" descr="0d40c52eb9dde352.png"/>
           <p:cNvPicPr>
             <a:picLocks noChangeAspect="1"/>
           </p:cNvPicPr>
@@ -30458,7 +30458,7 @@
       </p:sp>
       <p:pic>
         <p:nvPicPr>
-          <p:cNvPr id="9" name="mermaid diagram" descr="4cd06380afdb5b42.png"/>
+          <p:cNvPr id="9" name="mermaid diagram" descr="d0e861d03cb57114.png"/>
           <p:cNvPicPr>
             <a:picLocks noChangeAspect="1"/>
           </p:cNvPicPr>
@@ -32162,7 +32162,7 @@
       </p:sp>
       <p:pic>
         <p:nvPicPr>
-          <p:cNvPr id="9" name="mermaid diagram" descr="bf2295a3cfc083ac.png"/>
+          <p:cNvPr id="9" name="mermaid diagram" descr="76ef3f8a0b221813.png"/>
           <p:cNvPicPr>
             <a:picLocks noChangeAspect="1"/>
           </p:cNvPicPr>

</xml_diff>

<commit_message>
W02 D1 decks, notes, day sheet and TA note after the second review round: SECTION 7 asks about Finance's definition and its notes leave the filter to the room, S17's card states one filter without naming a status, S24 sizes the export as 1,000 orders and 340 customers, S57's last note names the route over the same 107, D19 and the notes stop naming the consumer reading; the day sheet and TA note carry every new key string, item 15's Rs 16,03,44,040 and one debrief order; both decks rebuilt and rendered
Co-Authored-By: Claude Opus 5.5 <noreply@anthropic.com>
Claude-Session: https://claude.ai/code/session_019sySp68P7Z1Q2VwZYDVRRe
</commit_message>
<xml_diff>
--- a/content/W02/D1/slides/C2_W02_D01_half2_STUDENT.pptx
+++ b/content/W02/D1/slides/C2_W02_D01_half2_STUDENT.pptx
@@ -1370,12 +1370,12 @@
           <a:lstStyle/>
           <a:p>
             <a:r>
-              <a:t>LIVE, 3 minutes. Read Anand's words aloud. Delivered means the order reached the customer and was</a:t>
-            </a:r>
-          </a:p>
-          <a:p>
-            <a:r>
-              <a:t>not returned or cancelled; on the book 653 of the 1,000 orders are delivered. Nothing from the</a:t>
+              <a:t>LIVE, 3 minutes. Read Anand's words aloud, and leave the definition's filter to the room: part 1's</a:t>
+            </a:r>
+          </a:p>
+          <a:p>
+            <a:r>
+              <a:t>first marker asks which orders it keeps. Nothing from the</a:t>
             </a:r>
           </a:p>
           <a:p>
@@ -1810,12 +1810,12 @@
           </a:p>
           <a:p>
             <a:r>
-              <a:t>three of the brief's own, and one line for Anand naming the channel losing its consumers fastest,</a:t>
-            </a:r>
-          </a:p>
-          <a:p>
-            <a:r>
-              <a:t>with its number.</a:t>
+              <a:t>three of the brief's own, and the line for Anand's channel sheet about Marketing's request, with the</a:t>
+            </a:r>
+          </a:p>
+          <a:p>
+            <a:r>
+              <a:t>number it rests on.</a:t>
             </a:r>
           </a:p>
         </p:txBody>
@@ -6312,7 +6312,7 @@
         <p:spPr>
           <a:xfrm>
             <a:off x="3056953" y="5870448"/>
-            <a:ext cx="1484185" cy="185166"/>
+            <a:ext cx="1425035" cy="185166"/>
           </a:xfrm>
           <a:prstGeom prst="rect">
             <a:avLst/>
@@ -6333,7 +6333,7 @@
                 </a:solidFill>
                 <a:latin typeface="Calibri"/>
               </a:rPr>
-              <a:t>Delivered orders only?</a:t>
+              <a:t>Finance's definition?</a:t>
             </a:r>
           </a:p>
         </p:txBody>
@@ -6346,7 +6346,7 @@
         </p:nvSpPr>
         <p:spPr>
           <a:xfrm>
-            <a:off x="4724019" y="5833872"/>
+            <a:off x="4664868" y="5833872"/>
             <a:ext cx="365760" cy="251205"/>
           </a:xfrm>
           <a:prstGeom prst="rect">
@@ -6381,7 +6381,7 @@
         </p:nvSpPr>
         <p:spPr>
           <a:xfrm>
-            <a:off x="5108067" y="5870448"/>
+            <a:off x="5048916" y="5870448"/>
             <a:ext cx="1484185" cy="185166"/>
           </a:xfrm>
           <a:prstGeom prst="rect">
@@ -7486,7 +7486,7 @@
         <p:spPr>
           <a:xfrm>
             <a:off x="2127694" y="6437376"/>
-            <a:ext cx="1286446" cy="152146"/>
+            <a:ext cx="1240440" cy="152146"/>
           </a:xfrm>
           <a:prstGeom prst="rect">
             <a:avLst/>
@@ -7507,7 +7507,7 @@
                 </a:solidFill>
                 <a:latin typeface="Calibri"/>
               </a:rPr>
-              <a:t>Delivered orders only?</a:t>
+              <a:t>Finance's definition?</a:t>
             </a:r>
           </a:p>
         </p:txBody>
@@ -7520,7 +7520,7 @@
         </p:nvSpPr>
         <p:spPr>
           <a:xfrm>
-            <a:off x="3505580" y="6492240"/>
+            <a:off x="3459575" y="6492240"/>
             <a:ext cx="64008" cy="64008"/>
           </a:xfrm>
           <a:prstGeom prst="ellipse">
@@ -7564,7 +7564,7 @@
         </p:nvSpPr>
         <p:spPr>
           <a:xfrm>
-            <a:off x="3615308" y="6437376"/>
+            <a:off x="3569303" y="6437376"/>
             <a:ext cx="1286446" cy="152146"/>
           </a:xfrm>
           <a:prstGeom prst="rect">
@@ -8391,7 +8391,7 @@
         <p:spPr>
           <a:xfrm>
             <a:off x="2127694" y="6437376"/>
-            <a:ext cx="1286446" cy="152146"/>
+            <a:ext cx="1240440" cy="152146"/>
           </a:xfrm>
           <a:prstGeom prst="rect">
             <a:avLst/>
@@ -8412,7 +8412,7 @@
                 </a:solidFill>
                 <a:latin typeface="Calibri"/>
               </a:rPr>
-              <a:t>Delivered orders only?</a:t>
+              <a:t>Finance's definition?</a:t>
             </a:r>
           </a:p>
         </p:txBody>
@@ -8425,7 +8425,7 @@
         </p:nvSpPr>
         <p:spPr>
           <a:xfrm>
-            <a:off x="3505580" y="6492240"/>
+            <a:off x="3459575" y="6492240"/>
             <a:ext cx="64008" cy="64008"/>
           </a:xfrm>
           <a:prstGeom prst="ellipse">
@@ -8469,7 +8469,7 @@
         </p:nvSpPr>
         <p:spPr>
           <a:xfrm>
-            <a:off x="3615308" y="6437376"/>
+            <a:off x="3569303" y="6437376"/>
             <a:ext cx="1286446" cy="152146"/>
           </a:xfrm>
           <a:prstGeom prst="rect">
@@ -9753,7 +9753,7 @@
         <p:spPr>
           <a:xfrm>
             <a:off x="2127694" y="6437376"/>
-            <a:ext cx="1286446" cy="152146"/>
+            <a:ext cx="1240440" cy="152146"/>
           </a:xfrm>
           <a:prstGeom prst="rect">
             <a:avLst/>
@@ -9774,7 +9774,7 @@
                 </a:solidFill>
                 <a:latin typeface="Calibri"/>
               </a:rPr>
-              <a:t>Delivered orders only?</a:t>
+              <a:t>Finance's definition?</a:t>
             </a:r>
           </a:p>
         </p:txBody>
@@ -9787,7 +9787,7 @@
         </p:nvSpPr>
         <p:spPr>
           <a:xfrm>
-            <a:off x="3505580" y="6492240"/>
+            <a:off x="3459575" y="6492240"/>
             <a:ext cx="64008" cy="64008"/>
           </a:xfrm>
           <a:prstGeom prst="ellipse">
@@ -9831,7 +9831,7 @@
         </p:nvSpPr>
         <p:spPr>
           <a:xfrm>
-            <a:off x="3615308" y="6437376"/>
+            <a:off x="3569303" y="6437376"/>
             <a:ext cx="1286446" cy="152146"/>
           </a:xfrm>
           <a:prstGeom prst="rect">
@@ -10427,7 +10427,7 @@
         <p:spPr>
           <a:xfrm>
             <a:off x="2127694" y="6437376"/>
-            <a:ext cx="1286446" cy="152146"/>
+            <a:ext cx="1240440" cy="152146"/>
           </a:xfrm>
           <a:prstGeom prst="rect">
             <a:avLst/>
@@ -10448,7 +10448,7 @@
                 </a:solidFill>
                 <a:latin typeface="Calibri"/>
               </a:rPr>
-              <a:t>Delivered orders only?</a:t>
+              <a:t>Finance's definition?</a:t>
             </a:r>
           </a:p>
         </p:txBody>
@@ -10461,7 +10461,7 @@
         </p:nvSpPr>
         <p:spPr>
           <a:xfrm>
-            <a:off x="3505580" y="6492240"/>
+            <a:off x="3459575" y="6492240"/>
             <a:ext cx="64008" cy="64008"/>
           </a:xfrm>
           <a:prstGeom prst="ellipse">
@@ -10505,7 +10505,7 @@
         </p:nvSpPr>
         <p:spPr>
           <a:xfrm>
-            <a:off x="3615308" y="6437376"/>
+            <a:off x="3569303" y="6437376"/>
             <a:ext cx="1286446" cy="152146"/>
           </a:xfrm>
           <a:prstGeom prst="rect">
@@ -11658,7 +11658,7 @@
         <p:spPr>
           <a:xfrm>
             <a:off x="2127694" y="6437376"/>
-            <a:ext cx="1286446" cy="152146"/>
+            <a:ext cx="1240440" cy="152146"/>
           </a:xfrm>
           <a:prstGeom prst="rect">
             <a:avLst/>
@@ -11679,7 +11679,7 @@
                 </a:solidFill>
                 <a:latin typeface="Calibri"/>
               </a:rPr>
-              <a:t>Delivered orders only?</a:t>
+              <a:t>Finance's definition?</a:t>
             </a:r>
           </a:p>
         </p:txBody>
@@ -11692,7 +11692,7 @@
         </p:nvSpPr>
         <p:spPr>
           <a:xfrm>
-            <a:off x="3505580" y="6492240"/>
+            <a:off x="3459575" y="6492240"/>
             <a:ext cx="64008" cy="64008"/>
           </a:xfrm>
           <a:prstGeom prst="ellipse">
@@ -11736,7 +11736,7 @@
         </p:nvSpPr>
         <p:spPr>
           <a:xfrm>
-            <a:off x="3615308" y="6437376"/>
+            <a:off x="3569303" y="6437376"/>
             <a:ext cx="1286446" cy="152146"/>
           </a:xfrm>
           <a:prstGeom prst="rect">
@@ -12229,7 +12229,7 @@
         <p:spPr>
           <a:xfrm>
             <a:off x="2127694" y="6437376"/>
-            <a:ext cx="1286446" cy="152146"/>
+            <a:ext cx="1240440" cy="152146"/>
           </a:xfrm>
           <a:prstGeom prst="rect">
             <a:avLst/>
@@ -12250,7 +12250,7 @@
                 </a:solidFill>
                 <a:latin typeface="Calibri"/>
               </a:rPr>
-              <a:t>Delivered orders only?</a:t>
+              <a:t>Finance's definition?</a:t>
             </a:r>
           </a:p>
         </p:txBody>
@@ -12263,7 +12263,7 @@
         </p:nvSpPr>
         <p:spPr>
           <a:xfrm>
-            <a:off x="3505580" y="6492240"/>
+            <a:off x="3459575" y="6492240"/>
             <a:ext cx="64008" cy="64008"/>
           </a:xfrm>
           <a:prstGeom prst="ellipse">
@@ -12307,7 +12307,7 @@
         </p:nvSpPr>
         <p:spPr>
           <a:xfrm>
-            <a:off x="3615308" y="6437376"/>
+            <a:off x="3569303" y="6437376"/>
             <a:ext cx="1286446" cy="152146"/>
           </a:xfrm>
           <a:prstGeom prst="rect">
@@ -12846,7 +12846,7 @@
         <p:spPr>
           <a:xfrm>
             <a:off x="2127694" y="6437376"/>
-            <a:ext cx="1286446" cy="152146"/>
+            <a:ext cx="1240440" cy="152146"/>
           </a:xfrm>
           <a:prstGeom prst="rect">
             <a:avLst/>
@@ -12867,7 +12867,7 @@
                 </a:solidFill>
                 <a:latin typeface="Calibri"/>
               </a:rPr>
-              <a:t>Delivered orders only?</a:t>
+              <a:t>Finance's definition?</a:t>
             </a:r>
           </a:p>
         </p:txBody>
@@ -12880,7 +12880,7 @@
         </p:nvSpPr>
         <p:spPr>
           <a:xfrm>
-            <a:off x="3505580" y="6492240"/>
+            <a:off x="3459575" y="6492240"/>
             <a:ext cx="64008" cy="64008"/>
           </a:xfrm>
           <a:prstGeom prst="ellipse">
@@ -12924,7 +12924,7 @@
         </p:nvSpPr>
         <p:spPr>
           <a:xfrm>
-            <a:off x="3615308" y="6437376"/>
+            <a:off x="3569303" y="6437376"/>
             <a:ext cx="1286446" cy="152146"/>
           </a:xfrm>
           <a:prstGeom prst="rect">
@@ -14043,7 +14043,7 @@
         <p:spPr>
           <a:xfrm>
             <a:off x="2127694" y="6437376"/>
-            <a:ext cx="1286446" cy="152146"/>
+            <a:ext cx="1240440" cy="152146"/>
           </a:xfrm>
           <a:prstGeom prst="rect">
             <a:avLst/>
@@ -14064,7 +14064,7 @@
                 </a:solidFill>
                 <a:latin typeface="Calibri"/>
               </a:rPr>
-              <a:t>Delivered orders only?</a:t>
+              <a:t>Finance's definition?</a:t>
             </a:r>
           </a:p>
         </p:txBody>
@@ -14077,7 +14077,7 @@
         </p:nvSpPr>
         <p:spPr>
           <a:xfrm>
-            <a:off x="3505580" y="6492240"/>
+            <a:off x="3459575" y="6492240"/>
             <a:ext cx="64008" cy="64008"/>
           </a:xfrm>
           <a:prstGeom prst="ellipse">
@@ -14121,7 +14121,7 @@
         </p:nvSpPr>
         <p:spPr>
           <a:xfrm>
-            <a:off x="3615308" y="6437376"/>
+            <a:off x="3569303" y="6437376"/>
             <a:ext cx="1286446" cy="152146"/>
           </a:xfrm>
           <a:prstGeom prst="rect">
@@ -14419,7 +14419,7 @@
                 </a:solidFill>
                 <a:latin typeface="Georgia"/>
               </a:rPr>
-              <a:t>Delivered orders only?</a:t>
+              <a:t>Finance's definition?</a:t>
             </a:r>
           </a:p>
         </p:txBody>
@@ -14454,7 +14454,7 @@
                 </a:solidFill>
                 <a:latin typeface="Calibri"/>
               </a:rPr>
-              <a:t>Does the Monday suite hold on Finance's definition, the orders that were delivered?</a:t>
+              <a:t>Does the Monday suite hold on Finance's definition of revenue?</a:t>
             </a:r>
           </a:p>
         </p:txBody>
@@ -14523,7 +14523,7 @@
         <p:spPr>
           <a:xfrm>
             <a:off x="2509759" y="5074920"/>
-            <a:ext cx="1668511" cy="310896"/>
+            <a:ext cx="1609295" cy="310896"/>
           </a:xfrm>
           <a:prstGeom prst="roundRect">
             <a:avLst>
@@ -14564,7 +14564,7 @@
                 </a:solidFill>
                 <a:latin typeface="Calibri"/>
               </a:rPr>
-              <a:t>Delivered orders only?</a:t>
+              <a:t>Finance's definition?</a:t>
             </a:r>
           </a:p>
         </p:txBody>
@@ -14577,7 +14577,7 @@
         </p:nvSpPr>
         <p:spPr>
           <a:xfrm>
-            <a:off x="4287998" y="5074920"/>
+            <a:off x="4228782" y="5074920"/>
             <a:ext cx="1668511" cy="310896"/>
           </a:xfrm>
           <a:prstGeom prst="roundRect">
@@ -15010,7 +15010,7 @@
                 </a:solidFill>
                 <a:latin typeface="Georgia"/>
               </a:rPr>
-              <a:t>"Finance counts the orders that reached the customer and stayed there. Run me the same suite on delivered orders, and tell me whether the story changes."</a:t>
+              <a:t>"Finance counts the orders that reached the customer and stayed there. Run me the same suite on that definition, and tell me whether the story changes."</a:t>
             </a:r>
           </a:p>
         </p:txBody>
@@ -15281,7 +15281,7 @@
         <p:spPr>
           <a:xfrm>
             <a:off x="694944" y="4501896"/>
-            <a:ext cx="1750710" cy="251205"/>
+            <a:ext cx="1750710" cy="465836"/>
           </a:xfrm>
           <a:prstGeom prst="rect">
             <a:avLst/>
@@ -15302,7 +15302,7 @@
                 </a:solidFill>
                 <a:latin typeface="Calibri"/>
               </a:rPr>
-              <a:t>The delivered book</a:t>
+              <a:t>On Finance's definition</a:t>
             </a:r>
           </a:p>
         </p:txBody>
@@ -15315,8 +15315,8 @@
         </p:nvSpPr>
         <p:spPr>
           <a:xfrm>
-            <a:off x="694944" y="4789678"/>
-            <a:ext cx="1750710" cy="696976"/>
+            <a:off x="694944" y="5004308"/>
+            <a:ext cx="1750710" cy="531876"/>
           </a:xfrm>
           <a:prstGeom prst="rect">
             <a:avLst/>
@@ -15337,7 +15337,7 @@
                 </a:solidFill>
                 <a:latin typeface="Calibri"/>
               </a:rPr>
-              <a:t>Orders, customers and rupees per quarter, on Finance's definition. This afternoon.</a:t>
+              <a:t>Orders, customers and rupees per quarter. This afternoon.</a:t>
             </a:r>
           </a:p>
         </p:txBody>
@@ -16292,7 +16292,7 @@
         <p:spPr>
           <a:xfrm>
             <a:off x="2127694" y="6437376"/>
-            <a:ext cx="1286446" cy="152146"/>
+            <a:ext cx="1240440" cy="152146"/>
           </a:xfrm>
           <a:prstGeom prst="rect">
             <a:avLst/>
@@ -16313,7 +16313,7 @@
                 </a:solidFill>
                 <a:latin typeface="Calibri"/>
               </a:rPr>
-              <a:t>Delivered orders only?</a:t>
+              <a:t>Finance's definition?</a:t>
             </a:r>
           </a:p>
         </p:txBody>
@@ -16326,7 +16326,7 @@
         </p:nvSpPr>
         <p:spPr>
           <a:xfrm>
-            <a:off x="3505580" y="6492240"/>
+            <a:off x="3459575" y="6492240"/>
             <a:ext cx="64008" cy="64008"/>
           </a:xfrm>
           <a:prstGeom prst="ellipse">
@@ -16370,7 +16370,7 @@
         </p:nvSpPr>
         <p:spPr>
           <a:xfrm>
-            <a:off x="3615308" y="6437376"/>
+            <a:off x="3569303" y="6437376"/>
             <a:ext cx="1286446" cy="152146"/>
           </a:xfrm>
           <a:prstGeom prst="rect">
@@ -17107,7 +17107,7 @@
         <p:spPr>
           <a:xfrm>
             <a:off x="2127694" y="6437376"/>
-            <a:ext cx="1286446" cy="152146"/>
+            <a:ext cx="1240440" cy="152146"/>
           </a:xfrm>
           <a:prstGeom prst="rect">
             <a:avLst/>
@@ -17128,7 +17128,7 @@
                 </a:solidFill>
                 <a:latin typeface="Calibri"/>
               </a:rPr>
-              <a:t>Delivered orders only?</a:t>
+              <a:t>Finance's definition?</a:t>
             </a:r>
           </a:p>
         </p:txBody>
@@ -17141,7 +17141,7 @@
         </p:nvSpPr>
         <p:spPr>
           <a:xfrm>
-            <a:off x="3505580" y="6492240"/>
+            <a:off x="3459575" y="6492240"/>
             <a:ext cx="64008" cy="64008"/>
           </a:xfrm>
           <a:prstGeom prst="ellipse">
@@ -17185,7 +17185,7 @@
         </p:nvSpPr>
         <p:spPr>
           <a:xfrm>
-            <a:off x="3615308" y="6437376"/>
+            <a:off x="3569303" y="6437376"/>
             <a:ext cx="1286446" cy="152146"/>
           </a:xfrm>
           <a:prstGeom prst="rect">
@@ -17448,7 +17448,7 @@
                 </a:solidFill>
                 <a:latin typeface="Georgia"/>
               </a:rPr>
-              <a:t>Delivered only, named counts, numeric, ordered</a:t>
+              <a:t>One stated filter, named counts, numeric, ordered</a:t>
             </a:r>
           </a:p>
         </p:txBody>
@@ -17483,7 +17483,7 @@
                 </a:solidFill>
                 <a:latin typeface="Calibri"/>
               </a:rPr>
-              <a:t>Which rules does the delivered suite have to keep, whatever the numbers turn out to be?</a:t>
+              <a:t>Which rules does the suite keep on Finance's definition, whatever the numbers turn out to be?</a:t>
             </a:r>
           </a:p>
         </p:txBody>
@@ -17675,7 +17675,7 @@
                 </a:solidFill>
                 <a:latin typeface="Calibri"/>
               </a:rPr>
-              <a:t>Delivered only</a:t>
+              <a:t>One filter, stated first</a:t>
             </a:r>
           </a:p>
         </p:txBody>
@@ -17710,7 +17710,7 @@
                 </a:solidFill>
                 <a:latin typeface="Calibri"/>
               </a:rPr>
-              <a:t>A filter on the order's status keeps orders that reached the customer and stayed.</a:t>
+              <a:t>One filter keeps only the orders that reached the customer and stayed there.</a:t>
             </a:r>
           </a:p>
         </p:txBody>
@@ -18534,7 +18534,7 @@
         <p:spPr>
           <a:xfrm>
             <a:off x="2127694" y="6437376"/>
-            <a:ext cx="1286446" cy="152146"/>
+            <a:ext cx="1240440" cy="152146"/>
           </a:xfrm>
           <a:prstGeom prst="rect">
             <a:avLst/>
@@ -18555,7 +18555,7 @@
                 </a:solidFill>
                 <a:latin typeface="Calibri"/>
               </a:rPr>
-              <a:t>Delivered orders only?</a:t>
+              <a:t>Finance's definition?</a:t>
             </a:r>
           </a:p>
         </p:txBody>
@@ -18568,7 +18568,7 @@
         </p:nvSpPr>
         <p:spPr>
           <a:xfrm>
-            <a:off x="3505580" y="6492240"/>
+            <a:off x="3459575" y="6492240"/>
             <a:ext cx="64008" cy="64008"/>
           </a:xfrm>
           <a:prstGeom prst="ellipse">
@@ -18612,7 +18612,7 @@
         </p:nvSpPr>
         <p:spPr>
           <a:xfrm>
-            <a:off x="3615308" y="6437376"/>
+            <a:off x="3569303" y="6437376"/>
             <a:ext cx="1286446" cy="152146"/>
           </a:xfrm>
           <a:prstGeom prst="rect">
@@ -19496,7 +19496,7 @@
         <p:spPr>
           <a:xfrm>
             <a:off x="2127694" y="6437376"/>
-            <a:ext cx="1286446" cy="152146"/>
+            <a:ext cx="1240440" cy="152146"/>
           </a:xfrm>
           <a:prstGeom prst="rect">
             <a:avLst/>
@@ -19517,7 +19517,7 @@
                 </a:solidFill>
                 <a:latin typeface="Calibri"/>
               </a:rPr>
-              <a:t>Delivered orders only?</a:t>
+              <a:t>Finance's definition?</a:t>
             </a:r>
           </a:p>
         </p:txBody>
@@ -19530,7 +19530,7 @@
         </p:nvSpPr>
         <p:spPr>
           <a:xfrm>
-            <a:off x="3505580" y="6492240"/>
+            <a:off x="3459575" y="6492240"/>
             <a:ext cx="64008" cy="64008"/>
           </a:xfrm>
           <a:prstGeom prst="ellipse">
@@ -19574,7 +19574,7 @@
         </p:nvSpPr>
         <p:spPr>
           <a:xfrm>
-            <a:off x="3615308" y="6437376"/>
+            <a:off x="3569303" y="6437376"/>
             <a:ext cx="1286446" cy="152146"/>
           </a:xfrm>
           <a:prstGeom prst="rect">
@@ -20412,7 +20412,7 @@
         <p:spPr>
           <a:xfrm>
             <a:off x="2127694" y="6437376"/>
-            <a:ext cx="1286446" cy="152146"/>
+            <a:ext cx="1240440" cy="152146"/>
           </a:xfrm>
           <a:prstGeom prst="rect">
             <a:avLst/>
@@ -20433,7 +20433,7 @@
                 </a:solidFill>
                 <a:latin typeface="Calibri"/>
               </a:rPr>
-              <a:t>Delivered orders only?</a:t>
+              <a:t>Finance's definition?</a:t>
             </a:r>
           </a:p>
         </p:txBody>
@@ -20446,7 +20446,7 @@
         </p:nvSpPr>
         <p:spPr>
           <a:xfrm>
-            <a:off x="3505580" y="6492240"/>
+            <a:off x="3459575" y="6492240"/>
             <a:ext cx="64008" cy="64008"/>
           </a:xfrm>
           <a:prstGeom prst="ellipse">
@@ -20490,7 +20490,7 @@
         </p:nvSpPr>
         <p:spPr>
           <a:xfrm>
-            <a:off x="3615308" y="6437376"/>
+            <a:off x="3569303" y="6437376"/>
             <a:ext cx="1286446" cy="152146"/>
           </a:xfrm>
           <a:prstGeom prst="rect">
@@ -21203,7 +21203,7 @@
         <p:spPr>
           <a:xfrm>
             <a:off x="2127694" y="6437376"/>
-            <a:ext cx="1286446" cy="152146"/>
+            <a:ext cx="1240440" cy="152146"/>
           </a:xfrm>
           <a:prstGeom prst="rect">
             <a:avLst/>
@@ -21224,7 +21224,7 @@
                 </a:solidFill>
                 <a:latin typeface="Calibri"/>
               </a:rPr>
-              <a:t>Delivered orders only?</a:t>
+              <a:t>Finance's definition?</a:t>
             </a:r>
           </a:p>
         </p:txBody>
@@ -21237,7 +21237,7 @@
         </p:nvSpPr>
         <p:spPr>
           <a:xfrm>
-            <a:off x="3505580" y="6492240"/>
+            <a:off x="3459575" y="6492240"/>
             <a:ext cx="64008" cy="64008"/>
           </a:xfrm>
           <a:prstGeom prst="ellipse">
@@ -21281,7 +21281,7 @@
         </p:nvSpPr>
         <p:spPr>
           <a:xfrm>
-            <a:off x="3615308" y="6437376"/>
+            <a:off x="3569303" y="6437376"/>
             <a:ext cx="1286446" cy="152146"/>
           </a:xfrm>
           <a:prstGeom prst="rect">
@@ -22274,7 +22274,7 @@
         <p:spPr>
           <a:xfrm>
             <a:off x="2127694" y="6437376"/>
-            <a:ext cx="1286446" cy="152146"/>
+            <a:ext cx="1240440" cy="152146"/>
           </a:xfrm>
           <a:prstGeom prst="rect">
             <a:avLst/>
@@ -22295,7 +22295,7 @@
                 </a:solidFill>
                 <a:latin typeface="Calibri"/>
               </a:rPr>
-              <a:t>Delivered orders only?</a:t>
+              <a:t>Finance's definition?</a:t>
             </a:r>
           </a:p>
         </p:txBody>
@@ -22308,7 +22308,7 @@
         </p:nvSpPr>
         <p:spPr>
           <a:xfrm>
-            <a:off x="3505580" y="6492240"/>
+            <a:off x="3459575" y="6492240"/>
             <a:ext cx="64008" cy="64008"/>
           </a:xfrm>
           <a:prstGeom prst="ellipse">
@@ -22352,7 +22352,7 @@
         </p:nvSpPr>
         <p:spPr>
           <a:xfrm>
-            <a:off x="3615308" y="6437376"/>
+            <a:off x="3569303" y="6437376"/>
             <a:ext cx="1286446" cy="152146"/>
           </a:xfrm>
           <a:prstGeom prst="rect">
@@ -22754,7 +22754,7 @@
         <p:spPr>
           <a:xfrm>
             <a:off x="2509759" y="5074920"/>
-            <a:ext cx="1668511" cy="310896"/>
+            <a:ext cx="1609295" cy="310896"/>
           </a:xfrm>
           <a:prstGeom prst="roundRect">
             <a:avLst>
@@ -22795,7 +22795,7 @@
                 </a:solidFill>
                 <a:latin typeface="Calibri"/>
               </a:rPr>
-              <a:t>Delivered orders only?</a:t>
+              <a:t>Finance's definition?</a:t>
             </a:r>
           </a:p>
         </p:txBody>
@@ -22808,7 +22808,7 @@
         </p:nvSpPr>
         <p:spPr>
           <a:xfrm>
-            <a:off x="4287998" y="5074920"/>
+            <a:off x="4228782" y="5074920"/>
             <a:ext cx="1668511" cy="310896"/>
           </a:xfrm>
           <a:prstGeom prst="roundRect">
@@ -24054,7 +24054,7 @@
         <p:spPr>
           <a:xfrm>
             <a:off x="2127694" y="6437376"/>
-            <a:ext cx="1286446" cy="152146"/>
+            <a:ext cx="1240440" cy="152146"/>
           </a:xfrm>
           <a:prstGeom prst="rect">
             <a:avLst/>
@@ -24075,7 +24075,7 @@
                 </a:solidFill>
                 <a:latin typeface="Calibri"/>
               </a:rPr>
-              <a:t>Delivered orders only?</a:t>
+              <a:t>Finance's definition?</a:t>
             </a:r>
           </a:p>
         </p:txBody>
@@ -24088,7 +24088,7 @@
         </p:nvSpPr>
         <p:spPr>
           <a:xfrm>
-            <a:off x="3505580" y="6492240"/>
+            <a:off x="3459575" y="6492240"/>
             <a:ext cx="64008" cy="64008"/>
           </a:xfrm>
           <a:prstGeom prst="ellipse">
@@ -24132,7 +24132,7 @@
         </p:nvSpPr>
         <p:spPr>
           <a:xfrm>
-            <a:off x="3615308" y="6437376"/>
+            <a:off x="3569303" y="6437376"/>
             <a:ext cx="1286446" cy="152146"/>
           </a:xfrm>
           <a:prstGeom prst="rect">
@@ -24915,7 +24915,7 @@
         <p:spPr>
           <a:xfrm>
             <a:off x="2127694" y="6437376"/>
-            <a:ext cx="1286446" cy="152146"/>
+            <a:ext cx="1240440" cy="152146"/>
           </a:xfrm>
           <a:prstGeom prst="rect">
             <a:avLst/>
@@ -24936,7 +24936,7 @@
                 </a:solidFill>
                 <a:latin typeface="Calibri"/>
               </a:rPr>
-              <a:t>Delivered orders only?</a:t>
+              <a:t>Finance's definition?</a:t>
             </a:r>
           </a:p>
         </p:txBody>
@@ -24949,7 +24949,7 @@
         </p:nvSpPr>
         <p:spPr>
           <a:xfrm>
-            <a:off x="3505580" y="6492240"/>
+            <a:off x="3459575" y="6492240"/>
             <a:ext cx="64008" cy="64008"/>
           </a:xfrm>
           <a:prstGeom prst="ellipse">
@@ -24993,7 +24993,7 @@
         </p:nvSpPr>
         <p:spPr>
           <a:xfrm>
-            <a:off x="3615308" y="6437376"/>
+            <a:off x="3569303" y="6437376"/>
             <a:ext cx="1286446" cy="152146"/>
           </a:xfrm>
           <a:prstGeom prst="rect">
@@ -25899,7 +25899,7 @@
         <p:spPr>
           <a:xfrm>
             <a:off x="2127694" y="6437376"/>
-            <a:ext cx="1286446" cy="152146"/>
+            <a:ext cx="1240440" cy="152146"/>
           </a:xfrm>
           <a:prstGeom prst="rect">
             <a:avLst/>
@@ -25920,7 +25920,7 @@
                 </a:solidFill>
                 <a:latin typeface="Calibri"/>
               </a:rPr>
-              <a:t>Delivered orders only?</a:t>
+              <a:t>Finance's definition?</a:t>
             </a:r>
           </a:p>
         </p:txBody>
@@ -25933,7 +25933,7 @@
         </p:nvSpPr>
         <p:spPr>
           <a:xfrm>
-            <a:off x="3505580" y="6492240"/>
+            <a:off x="3459575" y="6492240"/>
             <a:ext cx="64008" cy="64008"/>
           </a:xfrm>
           <a:prstGeom prst="ellipse">
@@ -25977,7 +25977,7 @@
         </p:nvSpPr>
         <p:spPr>
           <a:xfrm>
-            <a:off x="3615308" y="6437376"/>
+            <a:off x="3569303" y="6437376"/>
             <a:ext cx="1286446" cy="152146"/>
           </a:xfrm>
           <a:prstGeom prst="rect">
@@ -26596,7 +26596,7 @@
         <p:spPr>
           <a:xfrm>
             <a:off x="2127694" y="6437376"/>
-            <a:ext cx="1286446" cy="152146"/>
+            <a:ext cx="1240440" cy="152146"/>
           </a:xfrm>
           <a:prstGeom prst="rect">
             <a:avLst/>
@@ -26617,7 +26617,7 @@
                 </a:solidFill>
                 <a:latin typeface="Calibri"/>
               </a:rPr>
-              <a:t>Delivered orders only?</a:t>
+              <a:t>Finance's definition?</a:t>
             </a:r>
           </a:p>
         </p:txBody>
@@ -26630,7 +26630,7 @@
         </p:nvSpPr>
         <p:spPr>
           <a:xfrm>
-            <a:off x="3505580" y="6492240"/>
+            <a:off x="3459575" y="6492240"/>
             <a:ext cx="64008" cy="64008"/>
           </a:xfrm>
           <a:prstGeom prst="ellipse">
@@ -26674,7 +26674,7 @@
         </p:nvSpPr>
         <p:spPr>
           <a:xfrm>
-            <a:off x="3615308" y="6437376"/>
+            <a:off x="3569303" y="6437376"/>
             <a:ext cx="1286446" cy="152146"/>
           </a:xfrm>
           <a:prstGeom prst="rect">
@@ -27076,7 +27076,7 @@
         <p:spPr>
           <a:xfrm>
             <a:off x="2509759" y="5074920"/>
-            <a:ext cx="1668511" cy="310896"/>
+            <a:ext cx="1609295" cy="310896"/>
           </a:xfrm>
           <a:prstGeom prst="roundRect">
             <a:avLst>
@@ -27117,7 +27117,7 @@
                 </a:solidFill>
                 <a:latin typeface="Calibri"/>
               </a:rPr>
-              <a:t>Delivered orders only?</a:t>
+              <a:t>Finance's definition?</a:t>
             </a:r>
           </a:p>
         </p:txBody>
@@ -27130,7 +27130,7 @@
         </p:nvSpPr>
         <p:spPr>
           <a:xfrm>
-            <a:off x="4287998" y="5074920"/>
+            <a:off x="4228782" y="5074920"/>
             <a:ext cx="1668511" cy="310896"/>
           </a:xfrm>
           <a:prstGeom prst="roundRect">
@@ -28822,7 +28822,7 @@
         <p:spPr>
           <a:xfrm>
             <a:off x="2127694" y="6437376"/>
-            <a:ext cx="1286446" cy="152146"/>
+            <a:ext cx="1240440" cy="152146"/>
           </a:xfrm>
           <a:prstGeom prst="rect">
             <a:avLst/>
@@ -28843,7 +28843,7 @@
                 </a:solidFill>
                 <a:latin typeface="Calibri"/>
               </a:rPr>
-              <a:t>Delivered orders only?</a:t>
+              <a:t>Finance's definition?</a:t>
             </a:r>
           </a:p>
         </p:txBody>
@@ -28856,7 +28856,7 @@
         </p:nvSpPr>
         <p:spPr>
           <a:xfrm>
-            <a:off x="3505580" y="6492240"/>
+            <a:off x="3459575" y="6492240"/>
             <a:ext cx="64008" cy="64008"/>
           </a:xfrm>
           <a:prstGeom prst="ellipse">
@@ -28900,7 +28900,7 @@
         </p:nvSpPr>
         <p:spPr>
           <a:xfrm>
-            <a:off x="3615308" y="6437376"/>
+            <a:off x="3569303" y="6437376"/>
             <a:ext cx="1286446" cy="152146"/>
           </a:xfrm>
           <a:prstGeom prst="rect">
@@ -30022,7 +30022,7 @@
         <p:spPr>
           <a:xfrm>
             <a:off x="2127694" y="6437376"/>
-            <a:ext cx="1286446" cy="152146"/>
+            <a:ext cx="1240440" cy="152146"/>
           </a:xfrm>
           <a:prstGeom prst="rect">
             <a:avLst/>
@@ -30043,7 +30043,7 @@
                 </a:solidFill>
                 <a:latin typeface="Calibri"/>
               </a:rPr>
-              <a:t>Delivered orders only?</a:t>
+              <a:t>Finance's definition?</a:t>
             </a:r>
           </a:p>
         </p:txBody>
@@ -30056,7 +30056,7 @@
         </p:nvSpPr>
         <p:spPr>
           <a:xfrm>
-            <a:off x="3505580" y="6492240"/>
+            <a:off x="3459575" y="6492240"/>
             <a:ext cx="64008" cy="64008"/>
           </a:xfrm>
           <a:prstGeom prst="ellipse">
@@ -30100,7 +30100,7 @@
         </p:nvSpPr>
         <p:spPr>
           <a:xfrm>
-            <a:off x="3615308" y="6437376"/>
+            <a:off x="3569303" y="6437376"/>
             <a:ext cx="1286446" cy="152146"/>
           </a:xfrm>
           <a:prstGeom prst="rect">
@@ -30598,7 +30598,7 @@
         <p:spPr>
           <a:xfrm>
             <a:off x="2127694" y="6437376"/>
-            <a:ext cx="1286446" cy="152146"/>
+            <a:ext cx="1240440" cy="152146"/>
           </a:xfrm>
           <a:prstGeom prst="rect">
             <a:avLst/>
@@ -30619,7 +30619,7 @@
                 </a:solidFill>
                 <a:latin typeface="Calibri"/>
               </a:rPr>
-              <a:t>Delivered orders only?</a:t>
+              <a:t>Finance's definition?</a:t>
             </a:r>
           </a:p>
         </p:txBody>
@@ -30632,7 +30632,7 @@
         </p:nvSpPr>
         <p:spPr>
           <a:xfrm>
-            <a:off x="3505580" y="6492240"/>
+            <a:off x="3459575" y="6492240"/>
             <a:ext cx="64008" cy="64008"/>
           </a:xfrm>
           <a:prstGeom prst="ellipse">
@@ -30676,7 +30676,7 @@
         </p:nvSpPr>
         <p:spPr>
           <a:xfrm>
-            <a:off x="3615308" y="6437376"/>
+            <a:off x="3569303" y="6437376"/>
             <a:ext cx="1286446" cy="152146"/>
           </a:xfrm>
           <a:prstGeom prst="rect">
@@ -31726,7 +31726,7 @@
         <p:spPr>
           <a:xfrm>
             <a:off x="2127694" y="6437376"/>
-            <a:ext cx="1286446" cy="152146"/>
+            <a:ext cx="1240440" cy="152146"/>
           </a:xfrm>
           <a:prstGeom prst="rect">
             <a:avLst/>
@@ -31747,7 +31747,7 @@
                 </a:solidFill>
                 <a:latin typeface="Calibri"/>
               </a:rPr>
-              <a:t>Delivered orders only?</a:t>
+              <a:t>Finance's definition?</a:t>
             </a:r>
           </a:p>
         </p:txBody>
@@ -31760,7 +31760,7 @@
         </p:nvSpPr>
         <p:spPr>
           <a:xfrm>
-            <a:off x="3505580" y="6492240"/>
+            <a:off x="3459575" y="6492240"/>
             <a:ext cx="64008" cy="64008"/>
           </a:xfrm>
           <a:prstGeom prst="ellipse">
@@ -31804,7 +31804,7 @@
         </p:nvSpPr>
         <p:spPr>
           <a:xfrm>
-            <a:off x="3615308" y="6437376"/>
+            <a:off x="3569303" y="6437376"/>
             <a:ext cx="1286446" cy="152146"/>
           </a:xfrm>
           <a:prstGeom prst="rect">
@@ -32400,7 +32400,7 @@
         <p:spPr>
           <a:xfrm>
             <a:off x="2127694" y="6437376"/>
-            <a:ext cx="1286446" cy="152146"/>
+            <a:ext cx="1240440" cy="152146"/>
           </a:xfrm>
           <a:prstGeom prst="rect">
             <a:avLst/>
@@ -32421,7 +32421,7 @@
                 </a:solidFill>
                 <a:latin typeface="Calibri"/>
               </a:rPr>
-              <a:t>Delivered orders only?</a:t>
+              <a:t>Finance's definition?</a:t>
             </a:r>
           </a:p>
         </p:txBody>
@@ -32434,7 +32434,7 @@
         </p:nvSpPr>
         <p:spPr>
           <a:xfrm>
-            <a:off x="3505580" y="6492240"/>
+            <a:off x="3459575" y="6492240"/>
             <a:ext cx="64008" cy="64008"/>
           </a:xfrm>
           <a:prstGeom prst="ellipse">
@@ -32478,7 +32478,7 @@
         </p:nvSpPr>
         <p:spPr>
           <a:xfrm>
-            <a:off x="3615308" y="6437376"/>
+            <a:off x="3569303" y="6437376"/>
             <a:ext cx="1286446" cy="152146"/>
           </a:xfrm>
           <a:prstGeom prst="rect">
@@ -33369,7 +33369,7 @@
         <p:spPr>
           <a:xfrm>
             <a:off x="2127694" y="6437376"/>
-            <a:ext cx="1286446" cy="152146"/>
+            <a:ext cx="1240440" cy="152146"/>
           </a:xfrm>
           <a:prstGeom prst="rect">
             <a:avLst/>
@@ -33390,7 +33390,7 @@
                 </a:solidFill>
                 <a:latin typeface="Calibri"/>
               </a:rPr>
-              <a:t>Delivered orders only?</a:t>
+              <a:t>Finance's definition?</a:t>
             </a:r>
           </a:p>
         </p:txBody>
@@ -33403,7 +33403,7 @@
         </p:nvSpPr>
         <p:spPr>
           <a:xfrm>
-            <a:off x="3505580" y="6492240"/>
+            <a:off x="3459575" y="6492240"/>
             <a:ext cx="64008" cy="64008"/>
           </a:xfrm>
           <a:prstGeom prst="ellipse">
@@ -33447,7 +33447,7 @@
         </p:nvSpPr>
         <p:spPr>
           <a:xfrm>
-            <a:off x="3615308" y="6437376"/>
+            <a:off x="3569303" y="6437376"/>
             <a:ext cx="1286446" cy="152146"/>
           </a:xfrm>
           <a:prstGeom prst="rect">

</xml_diff>

<commit_message>
W02 D1 exercises, decks, notes and day sheet after the check of the second round's fixes: the escalated brief names its measure Finance's book and Finance's revenue throughout, item 9 offers a sort after the cut, item 15 option a names no status; the second case's item 2 asks for every Business order and no consumer order, item 8 sets four splits against each other by size, and its consumer tree is defined at step 3; chapter 4 item 6's option b is the fix's own average as a division, chapter 5 item 5's option d makes a false claim, chapter 6 item 5's option a reruns the service head's query; S7, S16, S17 and the notes no longer name the measure delivered or state a part's method; decks rebuilt and rendered
Co-Authored-By: Claude Opus 5.5 <noreply@anthropic.com>
Claude-Session: https://claude.ai/code/session_019sySp68P7Z1Q2VwZYDVRRe
</commit_message>
<xml_diff>
--- a/content/W02/D1/slides/C2_W02_D01_half2_STUDENT.pptx
+++ b/content/W02/D1/slides/C2_W02_D01_half2_STUDENT.pptx
@@ -16155,7 +16155,7 @@
                 </a:solidFill>
                 <a:latin typeface="Calibri"/>
               </a:rPr>
-              <a:t>An ordered sample and the delivered book's fingerprint. In the lab.</a:t>
+              <a:t>A sample the rerun draws again, and the book's fingerprint. In the lab.</a:t>
             </a:r>
           </a:p>
         </p:txBody>
@@ -17448,7 +17448,7 @@
                 </a:solidFill>
                 <a:latin typeface="Georgia"/>
               </a:rPr>
-              <a:t>One stated filter, named counts, numeric, ordered</a:t>
+              <a:t>Four rules hold the case to the morning's habits</a:t>
             </a:r>
           </a:p>
         </p:txBody>
@@ -17497,7 +17497,7 @@
         <p:spPr>
           <a:xfrm>
             <a:off x="530352" y="1956816"/>
-            <a:ext cx="2645587" cy="2385568"/>
+            <a:ext cx="2645587" cy="2575560"/>
           </a:xfrm>
           <a:prstGeom prst="roundRect">
             <a:avLst>
@@ -17724,7 +17724,7 @@
         <p:spPr>
           <a:xfrm>
             <a:off x="3358819" y="1956816"/>
-            <a:ext cx="2645587" cy="2385568"/>
+            <a:ext cx="2645587" cy="2575560"/>
           </a:xfrm>
           <a:prstGeom prst="roundRect">
             <a:avLst>
@@ -17916,7 +17916,7 @@
         <p:spPr>
           <a:xfrm>
             <a:off x="3559987" y="3534664"/>
-            <a:ext cx="2243251" cy="399796"/>
+            <a:ext cx="2243251" cy="581406"/>
           </a:xfrm>
           <a:prstGeom prst="rect">
             <a:avLst/>
@@ -17937,7 +17937,7 @@
                 </a:solidFill>
                 <a:latin typeface="Calibri"/>
               </a:rPr>
-              <a:t>Orders are rows; customers are counted once each.</a:t>
+              <a:t>Every count's name says what it counts, so no reader takes orders for customers.</a:t>
             </a:r>
           </a:p>
         </p:txBody>
@@ -17951,7 +17951,7 @@
         <p:spPr>
           <a:xfrm>
             <a:off x="6187287" y="1956816"/>
-            <a:ext cx="2645587" cy="2385568"/>
+            <a:ext cx="2645587" cy="2575560"/>
           </a:xfrm>
           <a:prstGeom prst="roundRect">
             <a:avLst>
@@ -18129,7 +18129,7 @@
                 </a:solidFill>
                 <a:latin typeface="Calibri"/>
               </a:rPr>
-              <a:t>Divided in numeric</a:t>
+              <a:t>Ratios that hold</a:t>
             </a:r>
           </a:p>
         </p:txBody>
@@ -18164,7 +18164,7 @@
                 </a:solidFill>
                 <a:latin typeface="Calibri"/>
               </a:rPr>
-              <a:t>Every ratio keeps its decimals and multiplies back to its orders.</a:t>
+              <a:t>Every ratio multiplies back to its orders, with its two counts printed beside it.</a:t>
             </a:r>
           </a:p>
         </p:txBody>
@@ -18178,7 +18178,7 @@
         <p:spPr>
           <a:xfrm>
             <a:off x="9015755" y="1956816"/>
-            <a:ext cx="2645587" cy="2385568"/>
+            <a:ext cx="2645587" cy="2575560"/>
           </a:xfrm>
           <a:prstGeom prst="roundRect">
             <a:avLst>
@@ -18362,7 +18362,7 @@
                 </a:solidFill>
                 <a:latin typeface="Calibri"/>
               </a:rPr>
-              <a:t>Ordered and fingerprinted</a:t>
+              <a:t>Repeated and fingerprinted</a:t>
             </a:r>
           </a:p>
         </p:txBody>
@@ -18376,7 +18376,7 @@
         <p:spPr>
           <a:xfrm>
             <a:off x="9216923" y="3534664"/>
-            <a:ext cx="2243251" cy="581406"/>
+            <a:ext cx="2243251" cy="763016"/>
           </a:xfrm>
           <a:prstGeom prst="rect">
             <a:avLst/>
@@ -18397,7 +18397,7 @@
                 </a:solidFill>
                 <a:latin typeface="Calibri"/>
               </a:rPr>
-              <a:t>The sample orders on a unique key, and the delivered book's fingerprint prints beside it.</a:t>
+              <a:t>The sample comes back the same on the analyst's rerun, and the book's fingerprint prints beside it.</a:t>
             </a:r>
           </a:p>
         </p:txBody>

</xml_diff>